<commit_message>
Refresh Ferrion logo with new metallic F-mark (site + documents)
Extract the two new AI-rendered logo images into a transparent
dark-background asset (public/logos/ferrion-full.webp) and swap it in
across all 12 site placements (header, footer, login, dashboard,
legal pages, structured data).

For the DOCX/PPTX document templates (white background), recolor the
wordmark to dark ink so it stays legible on paper while keeping the
metallic F-mark. Regenerate all 9 Word templates and both PowerPoint
masters with the new asset and its corrected aspect ratio.

Raw AI source renders moved to gitignored obsolete/ for reference.

Co-Authored-By: Claude Sonnet 5 <noreply@anthropic.com>
</commit_message>
<xml_diff>
--- a/templates/Ferrion-Praesentationsmaster-Hell.pptx
+++ b/templates/Ferrion-Praesentationsmaster-Hell.pptx
@@ -1872,7 +1872,7 @@
       </p:grpSpPr>
       <p:pic>
         <p:nvPicPr>
-          <p:cNvPr id="2" name="Image 0" descr="C:\stuff\ferrion\scripts\assets\ferrion-logo-light.png">    </p:cNvPr>
+          <p:cNvPr id="2" name="Image 0" descr="C:\Users\luciv\OneDrive\Dokumente\Privat\Firma\Homrpage\Source\scripts\assets\ferrion-logo-light.png">    </p:cNvPr>
           <p:cNvPicPr>
             <a:picLocks noChangeAspect="1"/>
           </p:cNvPicPr>
@@ -1887,7 +1887,7 @@
         <p:spPr>
           <a:xfrm>
             <a:off x="548640" y="502920"/>
-            <a:ext cx="2286000" cy="576072"/>
+            <a:ext cx="1078992" cy="576072"/>
           </a:xfrm>
           <a:prstGeom prst="rect">
             <a:avLst/>
@@ -2194,7 +2194,7 @@
       </p:sp>
       <p:pic>
         <p:nvPicPr>
-          <p:cNvPr id="4" name="Image 0" descr="C:\stuff\ferrion\scripts\assets\ferrion-logo-light.png">    </p:cNvPr>
+          <p:cNvPr id="4" name="Image 0" descr="C:\Users\luciv\OneDrive\Dokumente\Privat\Firma\Homrpage\Source\scripts\assets\ferrion-logo-light.png">    </p:cNvPr>
           <p:cNvPicPr>
             <a:picLocks noChangeAspect="1"/>
           </p:cNvPicPr>
@@ -2209,7 +2209,7 @@
         <p:spPr>
           <a:xfrm>
             <a:off x="548640" y="4160520"/>
-            <a:ext cx="1920240" cy="484632"/>
+            <a:ext cx="905256" cy="484632"/>
           </a:xfrm>
           <a:prstGeom prst="rect">
             <a:avLst/>

</xml_diff>